<commit_message>
Update Aqualogic Policy-at-a-Glance template
Replace the Policy-at-a-Glance PowerPoint with the updated version
placed in the templates folder. File is valid OOXML (opens in
PowerPoint).

Co-Authored-By: Claude Opus 4.8 <noreply@anthropic.com>
</commit_message>
<xml_diff>
--- a/public/assets/aqualogic/templates/Aqualogic_Policy_at_a_Glance_Template.pptx
+++ b/public/assets/aqualogic/templates/Aqualogic_Policy_at_a_Glance_Template.pptx
@@ -209,7 +209,7 @@
           <a:p>
             <a:fld id="{5282F153-3F37-0F45-9E97-73ACFA13230C}" type="datetimeFigureOut">
               <a:rPr lang="en-US"/>
-              <a:t>6/18/26</a:t>
+              <a:t>6/19/26</a:t>
             </a:fld>
             <a:endParaRPr lang="en-US"/>
           </a:p>
@@ -3655,7 +3655,7 @@
                 <a:ea typeface="Manrope" pitchFamily="34" charset="-122"/>
                 <a:cs typeface="Manrope" pitchFamily="34" charset="-120"/>
               </a:rPr>
-              <a:t>Health &amp; Safety, HR and Fleet include a worked example. Colours are a proposal and can be adjusted. Built in the Aqualogic brand (Manrope); install Manrope for correct rendering.</a:t>
+              <a:t>Health &amp; Safety, HR and Fleet include a worked, illustrative example. Colours are a proposal and can be adjusted. Built in the Aqualogic brand (Manrope); install Manrope for correct rendering.</a:t>
             </a:r>
             <a:endParaRPr lang="en-US" sz="950" dirty="0"/>
           </a:p>
@@ -14694,7 +14694,68 @@
       </p:sp>
       <p:sp>
         <p:nvSpPr>
-          <p:cNvPr id="5" name="Text 2"/>
+          <p:cNvPr id="5" name="Shape 2"/>
+          <p:cNvSpPr/>
+          <p:nvPr/>
+        </p:nvSpPr>
+        <p:spPr>
+          <a:xfrm>
+            <a:off x="5413248" y="749808"/>
+            <a:ext cx="1691640" cy="329184"/>
+          </a:xfrm>
+          <a:prstGeom prst="roundRect">
+            <a:avLst>
+              <a:gd name="adj" fmla="val 50000"/>
+            </a:avLst>
+          </a:prstGeom>
+          <a:solidFill>
+            <a:srgbClr val="FFFFFF"/>
+          </a:solidFill>
+          <a:ln/>
+        </p:spPr>
+      </p:sp>
+      <p:sp>
+        <p:nvSpPr>
+          <p:cNvPr id="6" name="Text 3"/>
+          <p:cNvSpPr/>
+          <p:nvPr/>
+        </p:nvSpPr>
+        <p:spPr>
+          <a:xfrm>
+            <a:off x="5413248" y="749808"/>
+            <a:ext cx="1691640" cy="329184"/>
+          </a:xfrm>
+          <a:prstGeom prst="rect">
+            <a:avLst/>
+          </a:prstGeom>
+          <a:noFill/>
+          <a:ln/>
+        </p:spPr>
+        <p:txBody>
+          <a:bodyPr wrap="square" lIns="0" tIns="0" rIns="0" bIns="0" rtlCol="0" anchor="ctr"/>
+          <a:lstStyle/>
+          <a:p>
+            <a:pPr marL="0" indent="0" algn="ctr">
+              <a:buNone/>
+            </a:pPr>
+            <a:r>
+              <a:rPr lang="en-US" sz="1050" b="1" kern="0" spc="100" dirty="0">
+                <a:solidFill>
+                  <a:srgbClr val="D6453D"/>
+                </a:solidFill>
+                <a:latin typeface="Manrope" pitchFamily="34" charset="0"/>
+                <a:ea typeface="Manrope" pitchFamily="34" charset="-122"/>
+                <a:cs typeface="Manrope" pitchFamily="34" charset="-120"/>
+              </a:rPr>
+              <a:t>EXAMPLE ONLY</a:t>
+            </a:r>
+            <a:endParaRPr lang="en-US" sz="1050" dirty="0"/>
+          </a:p>
+        </p:txBody>
+      </p:sp>
+      <p:sp>
+        <p:nvSpPr>
+          <p:cNvPr id="7" name="Text 4"/>
           <p:cNvSpPr/>
           <p:nvPr/>
         </p:nvSpPr>
@@ -14733,7 +14794,7 @@
       </p:sp>
       <p:sp>
         <p:nvSpPr>
-          <p:cNvPr id="6" name="Text 3"/>
+          <p:cNvPr id="8" name="Text 5"/>
           <p:cNvSpPr/>
           <p:nvPr/>
         </p:nvSpPr>
@@ -14772,7 +14833,7 @@
       </p:sp>
       <p:sp>
         <p:nvSpPr>
-          <p:cNvPr id="7" name="Shape 4"/>
+          <p:cNvPr id="9" name="Shape 6"/>
           <p:cNvSpPr/>
           <p:nvPr/>
         </p:nvSpPr>
@@ -14799,7 +14860,7 @@
       </p:sp>
       <p:sp>
         <p:nvSpPr>
-          <p:cNvPr id="8" name="Text 5"/>
+          <p:cNvPr id="10" name="Text 7"/>
           <p:cNvSpPr/>
           <p:nvPr/>
         </p:nvSpPr>
@@ -14852,7 +14913,7 @@
       </p:sp>
       <p:sp>
         <p:nvSpPr>
-          <p:cNvPr id="9" name="Text 6"/>
+          <p:cNvPr id="11" name="Text 8"/>
           <p:cNvSpPr/>
           <p:nvPr/>
         </p:nvSpPr>
@@ -14891,7 +14952,7 @@
       </p:sp>
       <p:sp>
         <p:nvSpPr>
-          <p:cNvPr id="10" name="Shape 7"/>
+          <p:cNvPr id="12" name="Shape 9"/>
           <p:cNvSpPr/>
           <p:nvPr/>
         </p:nvSpPr>
@@ -14913,7 +14974,7 @@
       </p:sp>
       <p:sp>
         <p:nvSpPr>
-          <p:cNvPr id="11" name="Text 8"/>
+          <p:cNvPr id="13" name="Text 10"/>
           <p:cNvSpPr/>
           <p:nvPr/>
         </p:nvSpPr>
@@ -14955,7 +15016,7 @@
       </p:sp>
       <p:sp>
         <p:nvSpPr>
-          <p:cNvPr id="12" name="Shape 9"/>
+          <p:cNvPr id="14" name="Shape 11"/>
           <p:cNvSpPr/>
           <p:nvPr/>
         </p:nvSpPr>
@@ -14975,7 +15036,7 @@
       </p:sp>
       <p:sp>
         <p:nvSpPr>
-          <p:cNvPr id="13" name="Shape 10"/>
+          <p:cNvPr id="15" name="Shape 12"/>
           <p:cNvSpPr/>
           <p:nvPr/>
         </p:nvSpPr>
@@ -14995,7 +15056,7 @@
       </p:sp>
       <p:sp>
         <p:nvSpPr>
-          <p:cNvPr id="14" name="Shape 11"/>
+          <p:cNvPr id="16" name="Shape 13"/>
           <p:cNvSpPr/>
           <p:nvPr/>
         </p:nvSpPr>
@@ -15015,7 +15076,7 @@
       </p:sp>
       <p:sp>
         <p:nvSpPr>
-          <p:cNvPr id="15" name="Shape 12"/>
+          <p:cNvPr id="17" name="Shape 14"/>
           <p:cNvSpPr/>
           <p:nvPr/>
         </p:nvSpPr>
@@ -15035,7 +15096,7 @@
       </p:sp>
       <p:sp>
         <p:nvSpPr>
-          <p:cNvPr id="16" name="Text 13"/>
+          <p:cNvPr id="18" name="Text 15"/>
           <p:cNvSpPr/>
           <p:nvPr/>
         </p:nvSpPr>
@@ -15074,7 +15135,7 @@
       </p:sp>
       <p:sp>
         <p:nvSpPr>
-          <p:cNvPr id="17" name="Text 14"/>
+          <p:cNvPr id="19" name="Text 16"/>
           <p:cNvSpPr/>
           <p:nvPr/>
         </p:nvSpPr>
@@ -15113,7 +15174,7 @@
       </p:sp>
       <p:sp>
         <p:nvSpPr>
-          <p:cNvPr id="18" name="Text 15"/>
+          <p:cNvPr id="20" name="Text 17"/>
           <p:cNvSpPr/>
           <p:nvPr/>
         </p:nvSpPr>
@@ -15152,7 +15213,7 @@
       </p:sp>
       <p:sp>
         <p:nvSpPr>
-          <p:cNvPr id="19" name="Text 16"/>
+          <p:cNvPr id="21" name="Text 18"/>
           <p:cNvSpPr/>
           <p:nvPr/>
         </p:nvSpPr>
@@ -15191,7 +15252,7 @@
       </p:sp>
       <p:sp>
         <p:nvSpPr>
-          <p:cNvPr id="20" name="Shape 17"/>
+          <p:cNvPr id="22" name="Shape 19"/>
           <p:cNvSpPr/>
           <p:nvPr/>
         </p:nvSpPr>
@@ -15218,7 +15279,7 @@
       </p:sp>
       <p:sp>
         <p:nvSpPr>
-          <p:cNvPr id="21" name="Text 18"/>
+          <p:cNvPr id="23" name="Text 20"/>
           <p:cNvSpPr/>
           <p:nvPr/>
         </p:nvSpPr>
@@ -15260,7 +15321,7 @@
       </p:sp>
       <p:sp>
         <p:nvSpPr>
-          <p:cNvPr id="22" name="Text 19"/>
+          <p:cNvPr id="24" name="Text 21"/>
           <p:cNvSpPr/>
           <p:nvPr/>
         </p:nvSpPr>
@@ -15299,7 +15360,7 @@
       </p:sp>
       <p:sp>
         <p:nvSpPr>
-          <p:cNvPr id="23" name="Shape 20"/>
+          <p:cNvPr id="25" name="Shape 22"/>
           <p:cNvSpPr/>
           <p:nvPr/>
         </p:nvSpPr>
@@ -15326,7 +15387,7 @@
       </p:sp>
       <p:sp>
         <p:nvSpPr>
-          <p:cNvPr id="24" name="Text 21"/>
+          <p:cNvPr id="26" name="Text 23"/>
           <p:cNvSpPr/>
           <p:nvPr/>
         </p:nvSpPr>
@@ -15368,7 +15429,7 @@
       </p:sp>
       <p:sp>
         <p:nvSpPr>
-          <p:cNvPr id="25" name="Shape 22"/>
+          <p:cNvPr id="27" name="Shape 24"/>
           <p:cNvSpPr/>
           <p:nvPr/>
         </p:nvSpPr>
@@ -15395,7 +15456,7 @@
       </p:sp>
       <p:sp>
         <p:nvSpPr>
-          <p:cNvPr id="26" name="Text 23"/>
+          <p:cNvPr id="28" name="Text 25"/>
           <p:cNvSpPr/>
           <p:nvPr/>
         </p:nvSpPr>
@@ -15437,7 +15498,7 @@
       </p:sp>
       <p:sp>
         <p:nvSpPr>
-          <p:cNvPr id="27" name="Text 24"/>
+          <p:cNvPr id="29" name="Text 26"/>
           <p:cNvSpPr/>
           <p:nvPr/>
         </p:nvSpPr>
@@ -15476,7 +15537,7 @@
       </p:sp>
       <p:sp>
         <p:nvSpPr>
-          <p:cNvPr id="28" name="Shape 25"/>
+          <p:cNvPr id="30" name="Shape 27"/>
           <p:cNvSpPr/>
           <p:nvPr/>
         </p:nvSpPr>
@@ -15503,7 +15564,7 @@
       </p:sp>
       <p:sp>
         <p:nvSpPr>
-          <p:cNvPr id="29" name="Text 26"/>
+          <p:cNvPr id="31" name="Text 28"/>
           <p:cNvSpPr/>
           <p:nvPr/>
         </p:nvSpPr>
@@ -15545,7 +15606,7 @@
       </p:sp>
       <p:sp>
         <p:nvSpPr>
-          <p:cNvPr id="30" name="Shape 27"/>
+          <p:cNvPr id="32" name="Shape 29"/>
           <p:cNvSpPr/>
           <p:nvPr/>
         </p:nvSpPr>
@@ -15565,7 +15626,7 @@
       </p:sp>
       <p:sp>
         <p:nvSpPr>
-          <p:cNvPr id="31" name="Shape 28"/>
+          <p:cNvPr id="33" name="Shape 30"/>
           <p:cNvSpPr/>
           <p:nvPr/>
         </p:nvSpPr>
@@ -15585,7 +15646,7 @@
       </p:sp>
       <p:sp>
         <p:nvSpPr>
-          <p:cNvPr id="32" name="Shape 29"/>
+          <p:cNvPr id="34" name="Shape 31"/>
           <p:cNvSpPr/>
           <p:nvPr/>
         </p:nvSpPr>
@@ -15605,7 +15666,7 @@
       </p:sp>
       <p:sp>
         <p:nvSpPr>
-          <p:cNvPr id="33" name="Shape 30"/>
+          <p:cNvPr id="35" name="Shape 32"/>
           <p:cNvSpPr/>
           <p:nvPr/>
         </p:nvSpPr>
@@ -15625,7 +15686,7 @@
       </p:sp>
       <p:sp>
         <p:nvSpPr>
-          <p:cNvPr id="34" name="Text 31"/>
+          <p:cNvPr id="36" name="Text 33"/>
           <p:cNvSpPr/>
           <p:nvPr/>
         </p:nvSpPr>
@@ -15664,7 +15725,7 @@
       </p:sp>
       <p:sp>
         <p:nvSpPr>
-          <p:cNvPr id="35" name="Shape 32"/>
+          <p:cNvPr id="37" name="Shape 34"/>
           <p:cNvSpPr/>
           <p:nvPr/>
         </p:nvSpPr>
@@ -15686,7 +15747,7 @@
       </p:sp>
       <p:sp>
         <p:nvSpPr>
-          <p:cNvPr id="36" name="Text 33"/>
+          <p:cNvPr id="38" name="Text 35"/>
           <p:cNvSpPr/>
           <p:nvPr/>
         </p:nvSpPr>
@@ -15728,7 +15789,7 @@
       </p:sp>
       <p:pic>
         <p:nvPicPr>
-          <p:cNvPr id="37" name="Image 1" descr="/home/claude/deck/img/mark.png"/>
+          <p:cNvPr id="39" name="Image 1" descr="/home/claude/deck/img/mark.png"/>
           <p:cNvPicPr>
             <a:picLocks noChangeAspect="1"/>
           </p:cNvPicPr>
@@ -15752,7 +15813,7 @@
       </p:pic>
       <p:sp>
         <p:nvSpPr>
-          <p:cNvPr id="38" name="Text 34"/>
+          <p:cNvPr id="40" name="Text 36"/>
           <p:cNvSpPr/>
           <p:nvPr/>
         </p:nvSpPr>
@@ -15791,7 +15852,7 @@
       </p:sp>
       <p:sp>
         <p:nvSpPr>
-          <p:cNvPr id="39" name="Text 35"/>
+          <p:cNvPr id="41" name="Text 37"/>
           <p:cNvSpPr/>
           <p:nvPr/>
         </p:nvSpPr>
@@ -15822,7 +15883,7 @@
                 <a:ea typeface="Manrope" pitchFamily="34" charset="-122"/>
                 <a:cs typeface="Manrope" pitchFamily="34" charset="-120"/>
               </a:rPr>
-              <a:t>For the detail, see the full procedure in the IMS.</a:t>
+              <a:t>Example content. Replace with your own.</a:t>
             </a:r>
             <a:endParaRPr lang="en-US" sz="900" dirty="0"/>
           </a:p>
@@ -15946,7 +16007,68 @@
       </p:sp>
       <p:sp>
         <p:nvSpPr>
-          <p:cNvPr id="5" name="Text 2"/>
+          <p:cNvPr id="5" name="Shape 2"/>
+          <p:cNvSpPr/>
+          <p:nvPr/>
+        </p:nvSpPr>
+        <p:spPr>
+          <a:xfrm>
+            <a:off x="5413248" y="749808"/>
+            <a:ext cx="1691640" cy="329184"/>
+          </a:xfrm>
+          <a:prstGeom prst="roundRect">
+            <a:avLst>
+              <a:gd name="adj" fmla="val 50000"/>
+            </a:avLst>
+          </a:prstGeom>
+          <a:solidFill>
+            <a:srgbClr val="FFFFFF"/>
+          </a:solidFill>
+          <a:ln/>
+        </p:spPr>
+      </p:sp>
+      <p:sp>
+        <p:nvSpPr>
+          <p:cNvPr id="6" name="Text 3"/>
+          <p:cNvSpPr/>
+          <p:nvPr/>
+        </p:nvSpPr>
+        <p:spPr>
+          <a:xfrm>
+            <a:off x="5413248" y="749808"/>
+            <a:ext cx="1691640" cy="329184"/>
+          </a:xfrm>
+          <a:prstGeom prst="rect">
+            <a:avLst/>
+          </a:prstGeom>
+          <a:noFill/>
+          <a:ln/>
+        </p:spPr>
+        <p:txBody>
+          <a:bodyPr wrap="square" lIns="0" tIns="0" rIns="0" bIns="0" rtlCol="0" anchor="ctr"/>
+          <a:lstStyle/>
+          <a:p>
+            <a:pPr marL="0" indent="0" algn="ctr">
+              <a:buNone/>
+            </a:pPr>
+            <a:r>
+              <a:rPr lang="en-US" sz="1050" b="1" kern="0" spc="100" dirty="0">
+                <a:solidFill>
+                  <a:srgbClr val="2E9E78"/>
+                </a:solidFill>
+                <a:latin typeface="Manrope" pitchFamily="34" charset="0"/>
+                <a:ea typeface="Manrope" pitchFamily="34" charset="-122"/>
+                <a:cs typeface="Manrope" pitchFamily="34" charset="-120"/>
+              </a:rPr>
+              <a:t>EXAMPLE ONLY</a:t>
+            </a:r>
+            <a:endParaRPr lang="en-US" sz="1050" dirty="0"/>
+          </a:p>
+        </p:txBody>
+      </p:sp>
+      <p:sp>
+        <p:nvSpPr>
+          <p:cNvPr id="7" name="Text 4"/>
           <p:cNvSpPr/>
           <p:nvPr/>
         </p:nvSpPr>
@@ -15985,7 +16107,7 @@
       </p:sp>
       <p:sp>
         <p:nvSpPr>
-          <p:cNvPr id="6" name="Text 3"/>
+          <p:cNvPr id="8" name="Text 5"/>
           <p:cNvSpPr/>
           <p:nvPr/>
         </p:nvSpPr>
@@ -16024,7 +16146,7 @@
       </p:sp>
       <p:sp>
         <p:nvSpPr>
-          <p:cNvPr id="7" name="Shape 4"/>
+          <p:cNvPr id="9" name="Shape 6"/>
           <p:cNvSpPr/>
           <p:nvPr/>
         </p:nvSpPr>
@@ -16044,7 +16166,7 @@
       </p:sp>
       <p:pic>
         <p:nvPicPr>
-          <p:cNvPr id="8" name="Image 1" descr="preencoded.png"/>
+          <p:cNvPr id="10" name="Image 1" descr="preencoded.png"/>
           <p:cNvPicPr>
             <a:picLocks noChangeAspect="1"/>
           </p:cNvPicPr>
@@ -16068,7 +16190,7 @@
       </p:pic>
       <p:sp>
         <p:nvSpPr>
-          <p:cNvPr id="9" name="Text 5"/>
+          <p:cNvPr id="11" name="Text 7"/>
           <p:cNvSpPr/>
           <p:nvPr/>
         </p:nvSpPr>
@@ -16110,7 +16232,7 @@
       </p:sp>
       <p:sp>
         <p:nvSpPr>
-          <p:cNvPr id="10" name="Text 6"/>
+          <p:cNvPr id="12" name="Text 8"/>
           <p:cNvSpPr/>
           <p:nvPr/>
         </p:nvSpPr>
@@ -16180,7 +16302,7 @@
       </p:sp>
       <p:sp>
         <p:nvSpPr>
-          <p:cNvPr id="11" name="Shape 7"/>
+          <p:cNvPr id="13" name="Shape 9"/>
           <p:cNvSpPr/>
           <p:nvPr/>
         </p:nvSpPr>
@@ -16200,7 +16322,7 @@
       </p:sp>
       <p:pic>
         <p:nvPicPr>
-          <p:cNvPr id="12" name="Image 2" descr="preencoded.png"/>
+          <p:cNvPr id="14" name="Image 2" descr="preencoded.png"/>
           <p:cNvPicPr>
             <a:picLocks noChangeAspect="1"/>
           </p:cNvPicPr>
@@ -16224,7 +16346,7 @@
       </p:pic>
       <p:sp>
         <p:nvSpPr>
-          <p:cNvPr id="13" name="Text 8"/>
+          <p:cNvPr id="15" name="Text 10"/>
           <p:cNvSpPr/>
           <p:nvPr/>
         </p:nvSpPr>
@@ -16266,7 +16388,7 @@
       </p:sp>
       <p:sp>
         <p:nvSpPr>
-          <p:cNvPr id="14" name="Text 9"/>
+          <p:cNvPr id="16" name="Text 11"/>
           <p:cNvSpPr/>
           <p:nvPr/>
         </p:nvSpPr>
@@ -16360,7 +16482,7 @@
       </p:sp>
       <p:sp>
         <p:nvSpPr>
-          <p:cNvPr id="15" name="Shape 10"/>
+          <p:cNvPr id="17" name="Shape 12"/>
           <p:cNvSpPr/>
           <p:nvPr/>
         </p:nvSpPr>
@@ -16380,7 +16502,7 @@
       </p:sp>
       <p:pic>
         <p:nvPicPr>
-          <p:cNvPr id="16" name="Image 3" descr="preencoded.png"/>
+          <p:cNvPr id="18" name="Image 3" descr="preencoded.png"/>
           <p:cNvPicPr>
             <a:picLocks noChangeAspect="1"/>
           </p:cNvPicPr>
@@ -16404,7 +16526,7 @@
       </p:pic>
       <p:sp>
         <p:nvSpPr>
-          <p:cNvPr id="17" name="Text 11"/>
+          <p:cNvPr id="19" name="Text 13"/>
           <p:cNvSpPr/>
           <p:nvPr/>
         </p:nvSpPr>
@@ -16446,7 +16568,7 @@
       </p:sp>
       <p:sp>
         <p:nvSpPr>
-          <p:cNvPr id="18" name="Text 12"/>
+          <p:cNvPr id="20" name="Text 14"/>
           <p:cNvSpPr/>
           <p:nvPr/>
         </p:nvSpPr>
@@ -16516,7 +16638,7 @@
       </p:sp>
       <p:sp>
         <p:nvSpPr>
-          <p:cNvPr id="19" name="Shape 13"/>
+          <p:cNvPr id="21" name="Shape 15"/>
           <p:cNvSpPr/>
           <p:nvPr/>
         </p:nvSpPr>
@@ -16536,7 +16658,7 @@
       </p:sp>
       <p:pic>
         <p:nvPicPr>
-          <p:cNvPr id="20" name="Image 4" descr="preencoded.png"/>
+          <p:cNvPr id="22" name="Image 4" descr="preencoded.png"/>
           <p:cNvPicPr>
             <a:picLocks noChangeAspect="1"/>
           </p:cNvPicPr>
@@ -16560,7 +16682,7 @@
       </p:pic>
       <p:sp>
         <p:nvSpPr>
-          <p:cNvPr id="21" name="Text 14"/>
+          <p:cNvPr id="23" name="Text 16"/>
           <p:cNvSpPr/>
           <p:nvPr/>
         </p:nvSpPr>
@@ -16602,7 +16724,7 @@
       </p:sp>
       <p:sp>
         <p:nvSpPr>
-          <p:cNvPr id="22" name="Text 15"/>
+          <p:cNvPr id="24" name="Text 17"/>
           <p:cNvSpPr/>
           <p:nvPr/>
         </p:nvSpPr>
@@ -16672,7 +16794,7 @@
       </p:sp>
       <p:sp>
         <p:nvSpPr>
-          <p:cNvPr id="23" name="Shape 16"/>
+          <p:cNvPr id="25" name="Shape 18"/>
           <p:cNvSpPr/>
           <p:nvPr/>
         </p:nvSpPr>
@@ -16692,7 +16814,7 @@
       </p:sp>
       <p:pic>
         <p:nvPicPr>
-          <p:cNvPr id="24" name="Image 5" descr="preencoded.png"/>
+          <p:cNvPr id="26" name="Image 5" descr="preencoded.png"/>
           <p:cNvPicPr>
             <a:picLocks noChangeAspect="1"/>
           </p:cNvPicPr>
@@ -16716,7 +16838,7 @@
       </p:pic>
       <p:sp>
         <p:nvSpPr>
-          <p:cNvPr id="25" name="Text 17"/>
+          <p:cNvPr id="27" name="Text 19"/>
           <p:cNvSpPr/>
           <p:nvPr/>
         </p:nvSpPr>
@@ -16758,7 +16880,7 @@
       </p:sp>
       <p:sp>
         <p:nvSpPr>
-          <p:cNvPr id="26" name="Text 18"/>
+          <p:cNvPr id="28" name="Text 20"/>
           <p:cNvSpPr/>
           <p:nvPr/>
         </p:nvSpPr>
@@ -16852,7 +16974,7 @@
       </p:sp>
       <p:sp>
         <p:nvSpPr>
-          <p:cNvPr id="27" name="Shape 19"/>
+          <p:cNvPr id="29" name="Shape 21"/>
           <p:cNvSpPr/>
           <p:nvPr/>
         </p:nvSpPr>
@@ -16874,7 +16996,7 @@
       </p:sp>
       <p:sp>
         <p:nvSpPr>
-          <p:cNvPr id="28" name="Text 20"/>
+          <p:cNvPr id="30" name="Text 22"/>
           <p:cNvSpPr/>
           <p:nvPr/>
         </p:nvSpPr>
@@ -16913,7 +17035,7 @@
       </p:sp>
       <p:sp>
         <p:nvSpPr>
-          <p:cNvPr id="29" name="Text 21"/>
+          <p:cNvPr id="31" name="Text 23"/>
           <p:cNvSpPr/>
           <p:nvPr/>
         </p:nvSpPr>
@@ -16963,7 +17085,7 @@
       </p:sp>
       <p:sp>
         <p:nvSpPr>
-          <p:cNvPr id="30" name="Text 22"/>
+          <p:cNvPr id="32" name="Text 24"/>
           <p:cNvSpPr/>
           <p:nvPr/>
         </p:nvSpPr>
@@ -16997,7 +17119,7 @@
                 <a:ea typeface="Manrope" pitchFamily="34" charset="-122"/>
                 <a:cs typeface="Manrope" pitchFamily="34" charset="-120"/>
               </a:rPr>
-              <a:t>3 absences in 26 weeks or 4 in 12 months. Documented discussion. 6-month review.</a:t>
+              <a:t>X absences in Y weeks, or X in Y months. Documented discussion. Y-month review.</a:t>
             </a:r>
             <a:endParaRPr lang="en-US" sz="950" dirty="0"/>
           </a:p>
@@ -17005,7 +17127,7 @@
       </p:sp>
       <p:sp>
         <p:nvSpPr>
-          <p:cNvPr id="31" name="Text 23"/>
+          <p:cNvPr id="33" name="Text 25"/>
           <p:cNvSpPr/>
           <p:nvPr/>
         </p:nvSpPr>
@@ -17055,7 +17177,7 @@
       </p:sp>
       <p:sp>
         <p:nvSpPr>
-          <p:cNvPr id="32" name="Text 24"/>
+          <p:cNvPr id="34" name="Text 26"/>
           <p:cNvSpPr/>
           <p:nvPr/>
         </p:nvSpPr>
@@ -17089,7 +17211,7 @@
                 <a:ea typeface="Manrope" pitchFamily="34" charset="-122"/>
                 <a:cs typeface="Manrope" pitchFamily="34" charset="-120"/>
               </a:rPr>
-              <a:t>Further absence in the review period. Formal meeting. 12-month review.</a:t>
+              <a:t>Further absence in the review period. Formal meeting. Y-month review.</a:t>
             </a:r>
             <a:endParaRPr lang="en-US" sz="950" dirty="0"/>
           </a:p>
@@ -17097,7 +17219,7 @@
       </p:sp>
       <p:sp>
         <p:nvSpPr>
-          <p:cNvPr id="33" name="Text 25"/>
+          <p:cNvPr id="35" name="Text 27"/>
           <p:cNvSpPr/>
           <p:nvPr/>
         </p:nvSpPr>
@@ -17147,7 +17269,7 @@
       </p:sp>
       <p:sp>
         <p:nvSpPr>
-          <p:cNvPr id="34" name="Text 26"/>
+          <p:cNvPr id="36" name="Text 28"/>
           <p:cNvSpPr/>
           <p:nvPr/>
         </p:nvSpPr>
@@ -17181,7 +17303,7 @@
                 <a:ea typeface="Manrope" pitchFamily="34" charset="-122"/>
                 <a:cs typeface="Manrope" pitchFamily="34" charset="-120"/>
               </a:rPr>
-              <a:t>Further absence in the review period. Formal meeting. 12-month review.</a:t>
+              <a:t>Further absence in the review period. Formal meeting. Y-month review.</a:t>
             </a:r>
             <a:endParaRPr lang="en-US" sz="950" dirty="0"/>
           </a:p>
@@ -17189,7 +17311,7 @@
       </p:sp>
       <p:sp>
         <p:nvSpPr>
-          <p:cNvPr id="35" name="Text 27"/>
+          <p:cNvPr id="37" name="Text 29"/>
           <p:cNvSpPr/>
           <p:nvPr/>
         </p:nvSpPr>
@@ -17239,7 +17361,7 @@
       </p:sp>
       <p:sp>
         <p:nvSpPr>
-          <p:cNvPr id="36" name="Text 28"/>
+          <p:cNvPr id="38" name="Text 30"/>
           <p:cNvSpPr/>
           <p:nvPr/>
         </p:nvSpPr>
@@ -17281,7 +17403,7 @@
       </p:sp>
       <p:sp>
         <p:nvSpPr>
-          <p:cNvPr id="37" name="Shape 29"/>
+          <p:cNvPr id="39" name="Shape 31"/>
           <p:cNvSpPr/>
           <p:nvPr/>
         </p:nvSpPr>
@@ -17303,7 +17425,7 @@
       </p:sp>
       <p:sp>
         <p:nvSpPr>
-          <p:cNvPr id="38" name="Text 30"/>
+          <p:cNvPr id="40" name="Text 32"/>
           <p:cNvSpPr/>
           <p:nvPr/>
         </p:nvSpPr>
@@ -17342,7 +17464,7 @@
       </p:sp>
       <p:sp>
         <p:nvSpPr>
-          <p:cNvPr id="39" name="Text 31"/>
+          <p:cNvPr id="41" name="Text 33"/>
           <p:cNvSpPr/>
           <p:nvPr/>
         </p:nvSpPr>
@@ -17484,7 +17606,7 @@
       </p:sp>
       <p:pic>
         <p:nvPicPr>
-          <p:cNvPr id="40" name="Image 6" descr="/home/claude/deck/img/mark.png"/>
+          <p:cNvPr id="42" name="Image 6" descr="/home/claude/deck/img/mark.png"/>
           <p:cNvPicPr>
             <a:picLocks noChangeAspect="1"/>
           </p:cNvPicPr>
@@ -17508,7 +17630,7 @@
       </p:pic>
       <p:sp>
         <p:nvSpPr>
-          <p:cNvPr id="41" name="Text 32"/>
+          <p:cNvPr id="43" name="Text 34"/>
           <p:cNvSpPr/>
           <p:nvPr/>
         </p:nvSpPr>
@@ -17547,7 +17669,7 @@
       </p:sp>
       <p:sp>
         <p:nvSpPr>
-          <p:cNvPr id="42" name="Text 33"/>
+          <p:cNvPr id="44" name="Text 35"/>
           <p:cNvSpPr/>
           <p:nvPr/>
         </p:nvSpPr>
@@ -17578,7 +17700,7 @@
                 <a:ea typeface="Manrope" pitchFamily="34" charset="-122"/>
                 <a:cs typeface="Manrope" pitchFamily="34" charset="-120"/>
               </a:rPr>
-              <a:t>For the detail, see the full policy in the employee handbook.</a:t>
+              <a:t>Example content. Replace with your own.</a:t>
             </a:r>
             <a:endParaRPr lang="en-US" sz="900" dirty="0"/>
           </a:p>
@@ -21310,7 +21432,68 @@
       </p:sp>
       <p:sp>
         <p:nvSpPr>
-          <p:cNvPr id="5" name="Text 2"/>
+          <p:cNvPr id="5" name="Shape 2"/>
+          <p:cNvSpPr/>
+          <p:nvPr/>
+        </p:nvSpPr>
+        <p:spPr>
+          <a:xfrm>
+            <a:off x="5413248" y="749808"/>
+            <a:ext cx="1691640" cy="329184"/>
+          </a:xfrm>
+          <a:prstGeom prst="roundRect">
+            <a:avLst>
+              <a:gd name="adj" fmla="val 50000"/>
+            </a:avLst>
+          </a:prstGeom>
+          <a:solidFill>
+            <a:srgbClr val="FFFFFF"/>
+          </a:solidFill>
+          <a:ln/>
+        </p:spPr>
+      </p:sp>
+      <p:sp>
+        <p:nvSpPr>
+          <p:cNvPr id="6" name="Text 3"/>
+          <p:cNvSpPr/>
+          <p:nvPr/>
+        </p:nvSpPr>
+        <p:spPr>
+          <a:xfrm>
+            <a:off x="5413248" y="749808"/>
+            <a:ext cx="1691640" cy="329184"/>
+          </a:xfrm>
+          <a:prstGeom prst="rect">
+            <a:avLst/>
+          </a:prstGeom>
+          <a:noFill/>
+          <a:ln/>
+        </p:spPr>
+        <p:txBody>
+          <a:bodyPr wrap="square" lIns="0" tIns="0" rIns="0" bIns="0" rtlCol="0" anchor="ctr"/>
+          <a:lstStyle/>
+          <a:p>
+            <a:pPr marL="0" indent="0" algn="ctr">
+              <a:buNone/>
+            </a:pPr>
+            <a:r>
+              <a:rPr lang="en-US" sz="1050" b="1" kern="0" spc="100" dirty="0">
+                <a:solidFill>
+                  <a:srgbClr val="E0922F"/>
+                </a:solidFill>
+                <a:latin typeface="Manrope" pitchFamily="34" charset="0"/>
+                <a:ea typeface="Manrope" pitchFamily="34" charset="-122"/>
+                <a:cs typeface="Manrope" pitchFamily="34" charset="-120"/>
+              </a:rPr>
+              <a:t>EXAMPLE ONLY</a:t>
+            </a:r>
+            <a:endParaRPr lang="en-US" sz="1050" dirty="0"/>
+          </a:p>
+        </p:txBody>
+      </p:sp>
+      <p:sp>
+        <p:nvSpPr>
+          <p:cNvPr id="7" name="Text 4"/>
           <p:cNvSpPr/>
           <p:nvPr/>
         </p:nvSpPr>
@@ -21349,7 +21532,7 @@
       </p:sp>
       <p:sp>
         <p:nvSpPr>
-          <p:cNvPr id="6" name="Text 3"/>
+          <p:cNvPr id="8" name="Text 5"/>
           <p:cNvSpPr/>
           <p:nvPr/>
         </p:nvSpPr>
@@ -21388,7 +21571,7 @@
       </p:sp>
       <p:sp>
         <p:nvSpPr>
-          <p:cNvPr id="7" name="Shape 4"/>
+          <p:cNvPr id="9" name="Shape 6"/>
           <p:cNvSpPr/>
           <p:nvPr/>
         </p:nvSpPr>
@@ -21410,7 +21593,7 @@
       </p:sp>
       <p:sp>
         <p:nvSpPr>
-          <p:cNvPr id="8" name="Shape 5"/>
+          <p:cNvPr id="10" name="Shape 7"/>
           <p:cNvSpPr/>
           <p:nvPr/>
         </p:nvSpPr>
@@ -21430,7 +21613,7 @@
       </p:sp>
       <p:pic>
         <p:nvPicPr>
-          <p:cNvPr id="9" name="Image 1" descr="preencoded.png"/>
+          <p:cNvPr id="11" name="Image 1" descr="preencoded.png"/>
           <p:cNvPicPr>
             <a:picLocks noChangeAspect="1"/>
           </p:cNvPicPr>
@@ -21454,7 +21637,7 @@
       </p:pic>
       <p:sp>
         <p:nvSpPr>
-          <p:cNvPr id="10" name="Text 6"/>
+          <p:cNvPr id="12" name="Text 8"/>
           <p:cNvSpPr/>
           <p:nvPr/>
         </p:nvSpPr>
@@ -21507,7 +21690,7 @@
       </p:sp>
       <p:sp>
         <p:nvSpPr>
-          <p:cNvPr id="11" name="Shape 7"/>
+          <p:cNvPr id="13" name="Shape 9"/>
           <p:cNvSpPr/>
           <p:nvPr/>
         </p:nvSpPr>
@@ -21534,7 +21717,7 @@
       </p:sp>
       <p:sp>
         <p:nvSpPr>
-          <p:cNvPr id="12" name="Shape 8"/>
+          <p:cNvPr id="14" name="Shape 10"/>
           <p:cNvSpPr/>
           <p:nvPr/>
         </p:nvSpPr>
@@ -21554,7 +21737,7 @@
       </p:sp>
       <p:sp>
         <p:nvSpPr>
-          <p:cNvPr id="13" name="Text 9"/>
+          <p:cNvPr id="15" name="Text 11"/>
           <p:cNvSpPr/>
           <p:nvPr/>
         </p:nvSpPr>
@@ -21593,7 +21776,7 @@
       </p:sp>
       <p:sp>
         <p:nvSpPr>
-          <p:cNvPr id="14" name="Text 10"/>
+          <p:cNvPr id="16" name="Text 12"/>
           <p:cNvSpPr/>
           <p:nvPr/>
         </p:nvSpPr>
@@ -21632,7 +21815,7 @@
       </p:sp>
       <p:sp>
         <p:nvSpPr>
-          <p:cNvPr id="15" name="Text 11"/>
+          <p:cNvPr id="17" name="Text 13"/>
           <p:cNvSpPr/>
           <p:nvPr/>
         </p:nvSpPr>
@@ -21674,7 +21857,7 @@
       </p:sp>
       <p:sp>
         <p:nvSpPr>
-          <p:cNvPr id="16" name="Text 12"/>
+          <p:cNvPr id="18" name="Text 14"/>
           <p:cNvSpPr/>
           <p:nvPr/>
         </p:nvSpPr>
@@ -21713,7 +21896,7 @@
       </p:sp>
       <p:sp>
         <p:nvSpPr>
-          <p:cNvPr id="17" name="Shape 13"/>
+          <p:cNvPr id="19" name="Shape 15"/>
           <p:cNvSpPr/>
           <p:nvPr/>
         </p:nvSpPr>
@@ -21740,7 +21923,7 @@
       </p:sp>
       <p:sp>
         <p:nvSpPr>
-          <p:cNvPr id="18" name="Shape 14"/>
+          <p:cNvPr id="20" name="Shape 16"/>
           <p:cNvSpPr/>
           <p:nvPr/>
         </p:nvSpPr>
@@ -21760,7 +21943,7 @@
       </p:sp>
       <p:sp>
         <p:nvSpPr>
-          <p:cNvPr id="19" name="Text 15"/>
+          <p:cNvPr id="21" name="Text 17"/>
           <p:cNvSpPr/>
           <p:nvPr/>
         </p:nvSpPr>
@@ -21799,7 +21982,7 @@
       </p:sp>
       <p:sp>
         <p:nvSpPr>
-          <p:cNvPr id="20" name="Text 16"/>
+          <p:cNvPr id="22" name="Text 18"/>
           <p:cNvSpPr/>
           <p:nvPr/>
         </p:nvSpPr>
@@ -21838,7 +22021,7 @@
       </p:sp>
       <p:sp>
         <p:nvSpPr>
-          <p:cNvPr id="21" name="Text 17"/>
+          <p:cNvPr id="23" name="Text 19"/>
           <p:cNvSpPr/>
           <p:nvPr/>
         </p:nvSpPr>
@@ -21880,7 +22063,7 @@
       </p:sp>
       <p:sp>
         <p:nvSpPr>
-          <p:cNvPr id="22" name="Text 18"/>
+          <p:cNvPr id="24" name="Text 20"/>
           <p:cNvSpPr/>
           <p:nvPr/>
         </p:nvSpPr>
@@ -21919,7 +22102,7 @@
       </p:sp>
       <p:sp>
         <p:nvSpPr>
-          <p:cNvPr id="23" name="Shape 19"/>
+          <p:cNvPr id="25" name="Shape 21"/>
           <p:cNvSpPr/>
           <p:nvPr/>
         </p:nvSpPr>
@@ -21946,7 +22129,7 @@
       </p:sp>
       <p:sp>
         <p:nvSpPr>
-          <p:cNvPr id="24" name="Shape 20"/>
+          <p:cNvPr id="26" name="Shape 22"/>
           <p:cNvSpPr/>
           <p:nvPr/>
         </p:nvSpPr>
@@ -21966,7 +22149,7 @@
       </p:sp>
       <p:sp>
         <p:nvSpPr>
-          <p:cNvPr id="25" name="Text 21"/>
+          <p:cNvPr id="27" name="Text 23"/>
           <p:cNvSpPr/>
           <p:nvPr/>
         </p:nvSpPr>
@@ -22005,7 +22188,7 @@
       </p:sp>
       <p:sp>
         <p:nvSpPr>
-          <p:cNvPr id="26" name="Text 22"/>
+          <p:cNvPr id="28" name="Text 24"/>
           <p:cNvSpPr/>
           <p:nvPr/>
         </p:nvSpPr>
@@ -22044,7 +22227,7 @@
       </p:sp>
       <p:sp>
         <p:nvSpPr>
-          <p:cNvPr id="27" name="Text 23"/>
+          <p:cNvPr id="29" name="Text 25"/>
           <p:cNvSpPr/>
           <p:nvPr/>
         </p:nvSpPr>
@@ -22086,7 +22269,7 @@
       </p:sp>
       <p:sp>
         <p:nvSpPr>
-          <p:cNvPr id="28" name="Text 24"/>
+          <p:cNvPr id="30" name="Text 26"/>
           <p:cNvSpPr/>
           <p:nvPr/>
         </p:nvSpPr>
@@ -22125,7 +22308,7 @@
       </p:sp>
       <p:sp>
         <p:nvSpPr>
-          <p:cNvPr id="29" name="Shape 25"/>
+          <p:cNvPr id="31" name="Shape 27"/>
           <p:cNvSpPr/>
           <p:nvPr/>
         </p:nvSpPr>
@@ -22152,7 +22335,7 @@
       </p:sp>
       <p:sp>
         <p:nvSpPr>
-          <p:cNvPr id="30" name="Shape 26"/>
+          <p:cNvPr id="32" name="Shape 28"/>
           <p:cNvSpPr/>
           <p:nvPr/>
         </p:nvSpPr>
@@ -22172,7 +22355,7 @@
       </p:sp>
       <p:sp>
         <p:nvSpPr>
-          <p:cNvPr id="31" name="Text 27"/>
+          <p:cNvPr id="33" name="Text 29"/>
           <p:cNvSpPr/>
           <p:nvPr/>
         </p:nvSpPr>
@@ -22211,7 +22394,7 @@
       </p:sp>
       <p:sp>
         <p:nvSpPr>
-          <p:cNvPr id="32" name="Text 28"/>
+          <p:cNvPr id="34" name="Text 30"/>
           <p:cNvSpPr/>
           <p:nvPr/>
         </p:nvSpPr>
@@ -22250,7 +22433,7 @@
       </p:sp>
       <p:sp>
         <p:nvSpPr>
-          <p:cNvPr id="33" name="Text 29"/>
+          <p:cNvPr id="35" name="Text 31"/>
           <p:cNvSpPr/>
           <p:nvPr/>
         </p:nvSpPr>
@@ -22292,7 +22475,7 @@
       </p:sp>
       <p:sp>
         <p:nvSpPr>
-          <p:cNvPr id="34" name="Text 30"/>
+          <p:cNvPr id="36" name="Text 32"/>
           <p:cNvSpPr/>
           <p:nvPr/>
         </p:nvSpPr>
@@ -22331,7 +22514,7 @@
       </p:sp>
       <p:sp>
         <p:nvSpPr>
-          <p:cNvPr id="35" name="Shape 31"/>
+          <p:cNvPr id="37" name="Shape 33"/>
           <p:cNvSpPr/>
           <p:nvPr/>
         </p:nvSpPr>
@@ -22358,7 +22541,7 @@
       </p:sp>
       <p:sp>
         <p:nvSpPr>
-          <p:cNvPr id="36" name="Shape 32"/>
+          <p:cNvPr id="38" name="Shape 34"/>
           <p:cNvSpPr/>
           <p:nvPr/>
         </p:nvSpPr>
@@ -22378,7 +22561,7 @@
       </p:sp>
       <p:sp>
         <p:nvSpPr>
-          <p:cNvPr id="37" name="Text 33"/>
+          <p:cNvPr id="39" name="Text 35"/>
           <p:cNvSpPr/>
           <p:nvPr/>
         </p:nvSpPr>
@@ -22417,7 +22600,7 @@
       </p:sp>
       <p:sp>
         <p:nvSpPr>
-          <p:cNvPr id="38" name="Text 34"/>
+          <p:cNvPr id="40" name="Text 36"/>
           <p:cNvSpPr/>
           <p:nvPr/>
         </p:nvSpPr>
@@ -22456,7 +22639,7 @@
       </p:sp>
       <p:sp>
         <p:nvSpPr>
-          <p:cNvPr id="39" name="Text 35"/>
+          <p:cNvPr id="41" name="Text 37"/>
           <p:cNvSpPr/>
           <p:nvPr/>
         </p:nvSpPr>
@@ -22498,7 +22681,7 @@
       </p:sp>
       <p:sp>
         <p:nvSpPr>
-          <p:cNvPr id="40" name="Shape 36"/>
+          <p:cNvPr id="42" name="Shape 38"/>
           <p:cNvSpPr/>
           <p:nvPr/>
         </p:nvSpPr>
@@ -22520,7 +22703,7 @@
       </p:sp>
       <p:sp>
         <p:nvSpPr>
-          <p:cNvPr id="41" name="Text 37"/>
+          <p:cNvPr id="43" name="Text 39"/>
           <p:cNvSpPr/>
           <p:nvPr/>
         </p:nvSpPr>
@@ -22559,7 +22742,7 @@
       </p:sp>
       <p:sp>
         <p:nvSpPr>
-          <p:cNvPr id="42" name="Text 38"/>
+          <p:cNvPr id="44" name="Text 40"/>
           <p:cNvSpPr/>
           <p:nvPr/>
         </p:nvSpPr>
@@ -22701,7 +22884,7 @@
       </p:sp>
       <p:sp>
         <p:nvSpPr>
-          <p:cNvPr id="43" name="Text 39"/>
+          <p:cNvPr id="45" name="Text 41"/>
           <p:cNvSpPr/>
           <p:nvPr/>
         </p:nvSpPr>
@@ -22740,7 +22923,7 @@
       </p:sp>
       <p:sp>
         <p:nvSpPr>
-          <p:cNvPr id="44" name="Text 40"/>
+          <p:cNvPr id="46" name="Text 42"/>
           <p:cNvSpPr/>
           <p:nvPr/>
         </p:nvSpPr>
@@ -22858,7 +23041,7 @@
       </p:sp>
       <p:sp>
         <p:nvSpPr>
-          <p:cNvPr id="45" name="Shape 41"/>
+          <p:cNvPr id="47" name="Shape 43"/>
           <p:cNvSpPr/>
           <p:nvPr/>
         </p:nvSpPr>
@@ -22880,7 +23063,7 @@
       </p:sp>
       <p:sp>
         <p:nvSpPr>
-          <p:cNvPr id="46" name="Text 42"/>
+          <p:cNvPr id="48" name="Text 44"/>
           <p:cNvSpPr/>
           <p:nvPr/>
         </p:nvSpPr>
@@ -22942,7 +23125,7 @@
       </p:sp>
       <p:pic>
         <p:nvPicPr>
-          <p:cNvPr id="47" name="Image 2" descr="/home/claude/deck/img/mark.png"/>
+          <p:cNvPr id="49" name="Image 2" descr="/home/claude/deck/img/mark.png"/>
           <p:cNvPicPr>
             <a:picLocks noChangeAspect="1"/>
           </p:cNvPicPr>
@@ -22966,7 +23149,7 @@
       </p:pic>
       <p:sp>
         <p:nvSpPr>
-          <p:cNvPr id="48" name="Text 43"/>
+          <p:cNvPr id="50" name="Text 45"/>
           <p:cNvSpPr/>
           <p:nvPr/>
         </p:nvSpPr>
@@ -23005,7 +23188,7 @@
       </p:sp>
       <p:sp>
         <p:nvSpPr>
-          <p:cNvPr id="49" name="Text 44"/>
+          <p:cNvPr id="51" name="Text 46"/>
           <p:cNvSpPr/>
           <p:nvPr/>
         </p:nvSpPr>
@@ -23036,7 +23219,7 @@
                 <a:ea typeface="Manrope" pitchFamily="34" charset="-122"/>
                 <a:cs typeface="Manrope" pitchFamily="34" charset="-120"/>
               </a:rPr>
-              <a:t>For the detail, see the full procedure in the IMS.</a:t>
+              <a:t>Example content. Replace with your own.</a:t>
             </a:r>
             <a:endParaRPr lang="en-US" sz="900" dirty="0"/>
           </a:p>

</xml_diff>